<commit_message>
chore: baseline updates prior to demo flow
</commit_message>
<xml_diff>
--- a/docs/Sonar_-_Kevin_Horner_SE_Interview.pptx
+++ b/docs/Sonar_-_Kevin_Horner_SE_Interview.pptx
@@ -457,10 +457,10 @@
           <a:p>
             <a:r>
               <a:rPr lang="en-US" dirty="0"/>
-              <a:t>You run one of the most sophisticated engineering organizations in the world. You invested $1.7 billion in R&amp;D in 2023. You operate the second largest MySQL fleet outside of Meta. The talent you've assembled is best-in-class at every level.
+              <a:t>At Shopify, you run one of the most sophisticated engineering organizations in the world. Since 2022, you’ve consistently invested over $1 billion per year in R&amp;D, with $1.7 billion in 2023. You operate the second largest MySQL fleet outside of Meta. The talent you've assembled is best-in-class at every level.
 In November, Shopify called a Code Red.
 Farhan described it on The Pragmatic Engineer Podcast. His words: 'We didn't think it was going to be 7 months — we thought it was going to be maybe 3 months. And we took something between like 30 to 50% of engineering. We didn't have an actual number.'
-Run that math. Seven months. Thirty to fifty percent of a $1.7 billion engineering investment. Between $297 million and $496 million of engineering capacity — frozen. No feature velocity. No product progress.
+Run that math. Seven months. Thirty to fifty percent of a $1.7 billion engineering investment. Between $297 million and $496 million of engineering capacity — frozen. No feature velocity. No product progress. No actual number.
 The org didn't know how much of itself was frozen. It just knew it had stopped.
 They stabilized.</a:t>
             </a:r>

</xml_diff>